<commit_message>
feat: enhance presentation with new images and updated content for KPI cards and sentiment heatmap
</commit_message>
<xml_diff>
--- a/presentation/RevuMind_V2_Presentation.pptx
+++ b/presentation/RevuMind_V2_Presentation.pptx
@@ -6625,62 +6625,103 @@
           </a:effectLst>
         </p:spPr>
       </p:sp>
-      <p:sp>
-        <p:nvSpPr>
-          <p:cNvPr id="6" name="Shape 3"/>
-          <p:cNvSpPr/>
-          <p:nvPr/>
-        </p:nvSpPr>
+      <p:pic>
+        <p:nvPicPr>
+          <p:cNvPr id="6" name="Image 1" descr="/Users/amanmeena/Documents/Work/RevuMind/reports/figures/real_time_kpi_cards.jpg">    </p:cNvPr>
+          <p:cNvPicPr>
+            <a:picLocks noChangeAspect="1"/>
+          </p:cNvPicPr>
+          <p:nvPr/>
+        </p:nvPicPr>
+        <p:blipFill>
+          <a:blip r:embed="rId2"/>
+          <a:stretch>
+            <a:fillRect/>
+          </a:stretch>
+        </p:blipFill>
         <p:spPr>
           <a:xfrm>
             <a:off x="594360" y="1280160"/>
             <a:ext cx="2286000" cy="1920240"/>
           </a:xfrm>
-          <a:prstGeom prst="roundRect">
-            <a:avLst>
-              <a:gd name="adj" fmla="val 3810"/>
-            </a:avLst>
-          </a:prstGeom>
-          <a:solidFill>
-            <a:srgbClr val="EBF5FB"/>
-          </a:solidFill>
-          <a:ln/>
-        </p:spPr>
-      </p:sp>
-      <p:sp>
-        <p:nvSpPr>
-          <p:cNvPr id="7" name="Text 4"/>
-          <p:cNvSpPr/>
-          <p:nvPr/>
-        </p:nvSpPr>
-        <p:spPr>
-          <a:xfrm>
-            <a:off x="594360" y="1280160"/>
-            <a:ext cx="2286000" cy="914400"/>
-          </a:xfrm>
-          <a:prstGeom prst="rect">
-            <a:avLst/>
-          </a:prstGeom>
-          <a:noFill/>
-          <a:ln/>
-        </p:spPr>
-        <p:txBody>
-          <a:bodyPr wrap="square" rtlCol="0" anchor="b"/>
+          <a:prstGeom prst="rect">
+            <a:avLst/>
+          </a:prstGeom>
+        </p:spPr>
+      </p:pic>
+      <p:sp>
+        <p:nvSpPr>
+          <p:cNvPr id="7" name="Text 3"/>
+          <p:cNvSpPr/>
+          <p:nvPr/>
+        </p:nvSpPr>
+        <p:spPr>
+          <a:xfrm>
+            <a:off x="548640" y="3383280"/>
+            <a:ext cx="2377440" cy="365760"/>
+          </a:xfrm>
+          <a:prstGeom prst="rect">
+            <a:avLst/>
+          </a:prstGeom>
+          <a:noFill/>
+          <a:ln/>
+        </p:spPr>
+        <p:txBody>
+          <a:bodyPr wrap="square" lIns="0" tIns="0" rIns="0" bIns="0" rtlCol="0" anchor="ctr"/>
           <a:lstStyle/>
           <a:p>
             <a:pPr algn="ctr" indent="0" marL="0">
               <a:buNone/>
             </a:pPr>
             <a:r>
-              <a:rPr lang="en-US" sz="1050" i="1" dirty="0">
+              <a:rPr lang="en-US" sz="1200" b="1" dirty="0">
                 <a:solidFill>
                   <a:srgbClr val="1F2833"/>
+                </a:solidFill>
+                <a:latin typeface="Cambria" pitchFamily="34" charset="0"/>
+                <a:ea typeface="Cambria" pitchFamily="34" charset="-122"/>
+                <a:cs typeface="Cambria" pitchFamily="34" charset="-120"/>
+              </a:rPr>
+              <a:t>Real-Time KPI Cards</a:t>
+            </a:r>
+            <a:endParaRPr lang="en-US" sz="1200" dirty="0"/>
+          </a:p>
+        </p:txBody>
+      </p:sp>
+      <p:sp>
+        <p:nvSpPr>
+          <p:cNvPr id="8" name="Text 4"/>
+          <p:cNvSpPr/>
+          <p:nvPr/>
+        </p:nvSpPr>
+        <p:spPr>
+          <a:xfrm>
+            <a:off x="548640" y="3794760"/>
+            <a:ext cx="2377440" cy="731520"/>
+          </a:xfrm>
+          <a:prstGeom prst="rect">
+            <a:avLst/>
+          </a:prstGeom>
+          <a:noFill/>
+          <a:ln/>
+        </p:spPr>
+        <p:txBody>
+          <a:bodyPr wrap="square" lIns="0" tIns="0" rIns="0" bIns="0" rtlCol="0" anchor="ctr"/>
+          <a:lstStyle/>
+          <a:p>
+            <a:pPr algn="ctr" indent="0" marL="0">
+              <a:buNone/>
+            </a:pPr>
+            <a:r>
+              <a:rPr lang="en-US" sz="1050" dirty="0">
+                <a:solidFill>
+                  <a:srgbClr val="64748B"/>
                 </a:solidFill>
                 <a:latin typeface="Calibri" pitchFamily="34" charset="0"/>
                 <a:ea typeface="Calibri" pitchFamily="34" charset="-122"/>
                 <a:cs typeface="Calibri" pitchFamily="34" charset="-120"/>
               </a:rPr>
-              <a:t>[ Streamlit Visualization ]</a:t>
+              <a:t>Monitors review volumes, sentiment ratios, and helpfulness metrics dynamically.</a:t>
             </a:r>
             <a:endParaRPr lang="en-US" sz="1050" dirty="0"/>
           </a:p>
@@ -6688,85 +6729,7 @@
       </p:sp>
       <p:sp>
         <p:nvSpPr>
-          <p:cNvPr id="8" name="Text 5"/>
-          <p:cNvSpPr/>
-          <p:nvPr/>
-        </p:nvSpPr>
-        <p:spPr>
-          <a:xfrm>
-            <a:off x="548640" y="3383280"/>
-            <a:ext cx="2377440" cy="365760"/>
-          </a:xfrm>
-          <a:prstGeom prst="rect">
-            <a:avLst/>
-          </a:prstGeom>
-          <a:noFill/>
-          <a:ln/>
-        </p:spPr>
-        <p:txBody>
-          <a:bodyPr wrap="square" lIns="0" tIns="0" rIns="0" bIns="0" rtlCol="0" anchor="ctr"/>
-          <a:lstStyle/>
-          <a:p>
-            <a:pPr algn="ctr" indent="0" marL="0">
-              <a:buNone/>
-            </a:pPr>
-            <a:r>
-              <a:rPr lang="en-US" sz="1200" b="1" dirty="0">
-                <a:solidFill>
-                  <a:srgbClr val="1F2833"/>
-                </a:solidFill>
-                <a:latin typeface="Cambria" pitchFamily="34" charset="0"/>
-                <a:ea typeface="Cambria" pitchFamily="34" charset="-122"/>
-                <a:cs typeface="Cambria" pitchFamily="34" charset="-120"/>
-              </a:rPr>
-              <a:t>Real-Time KPI Cards</a:t>
-            </a:r>
-            <a:endParaRPr lang="en-US" sz="1200" dirty="0"/>
-          </a:p>
-        </p:txBody>
-      </p:sp>
-      <p:sp>
-        <p:nvSpPr>
-          <p:cNvPr id="9" name="Text 6"/>
-          <p:cNvSpPr/>
-          <p:nvPr/>
-        </p:nvSpPr>
-        <p:spPr>
-          <a:xfrm>
-            <a:off x="548640" y="3794760"/>
-            <a:ext cx="2377440" cy="731520"/>
-          </a:xfrm>
-          <a:prstGeom prst="rect">
-            <a:avLst/>
-          </a:prstGeom>
-          <a:noFill/>
-          <a:ln/>
-        </p:spPr>
-        <p:txBody>
-          <a:bodyPr wrap="square" lIns="0" tIns="0" rIns="0" bIns="0" rtlCol="0" anchor="ctr"/>
-          <a:lstStyle/>
-          <a:p>
-            <a:pPr algn="ctr" indent="0" marL="0">
-              <a:buNone/>
-            </a:pPr>
-            <a:r>
-              <a:rPr lang="en-US" sz="1050" dirty="0">
-                <a:solidFill>
-                  <a:srgbClr val="64748B"/>
-                </a:solidFill>
-                <a:latin typeface="Calibri" pitchFamily="34" charset="0"/>
-                <a:ea typeface="Calibri" pitchFamily="34" charset="-122"/>
-                <a:cs typeface="Calibri" pitchFamily="34" charset="-120"/>
-              </a:rPr>
-              <a:t>Monitors review volumes, sentiment ratios, and helpfulness metrics dynamically.</a:t>
-            </a:r>
-            <a:endParaRPr lang="en-US" sz="1050" dirty="0"/>
-          </a:p>
-        </p:txBody>
-      </p:sp>
-      <p:sp>
-        <p:nvSpPr>
-          <p:cNvPr id="10" name="Shape 7"/>
+          <p:cNvPr id="9" name="Shape 5"/>
           <p:cNvSpPr/>
           <p:nvPr/>
         </p:nvSpPr>
@@ -6793,62 +6756,103 @@
           </a:effectLst>
         </p:spPr>
       </p:sp>
-      <p:sp>
-        <p:nvSpPr>
-          <p:cNvPr id="11" name="Shape 8"/>
-          <p:cNvSpPr/>
-          <p:nvPr/>
-        </p:nvSpPr>
+      <p:pic>
+        <p:nvPicPr>
+          <p:cNvPr id="10" name="Image 2" descr="/Users/amanmeena/Documents/Work/RevuMind/reports/figures/aspect_sentiment_heatmap.jpg">    </p:cNvPr>
+          <p:cNvPicPr>
+            <a:picLocks noChangeAspect="1"/>
+          </p:cNvPicPr>
+          <p:nvPr/>
+        </p:nvPicPr>
+        <p:blipFill>
+          <a:blip r:embed="rId3"/>
+          <a:stretch>
+            <a:fillRect/>
+          </a:stretch>
+        </p:blipFill>
         <p:spPr>
           <a:xfrm>
             <a:off x="3429000" y="1280160"/>
             <a:ext cx="2286000" cy="1920240"/>
           </a:xfrm>
-          <a:prstGeom prst="roundRect">
-            <a:avLst>
-              <a:gd name="adj" fmla="val 3810"/>
-            </a:avLst>
-          </a:prstGeom>
-          <a:solidFill>
-            <a:srgbClr val="EBF5FB"/>
-          </a:solidFill>
-          <a:ln/>
-        </p:spPr>
-      </p:sp>
-      <p:sp>
-        <p:nvSpPr>
-          <p:cNvPr id="12" name="Text 9"/>
-          <p:cNvSpPr/>
-          <p:nvPr/>
-        </p:nvSpPr>
-        <p:spPr>
-          <a:xfrm>
-            <a:off x="3429000" y="1280160"/>
-            <a:ext cx="2286000" cy="914400"/>
-          </a:xfrm>
-          <a:prstGeom prst="rect">
-            <a:avLst/>
-          </a:prstGeom>
-          <a:noFill/>
-          <a:ln/>
-        </p:spPr>
-        <p:txBody>
-          <a:bodyPr wrap="square" rtlCol="0" anchor="b"/>
+          <a:prstGeom prst="rect">
+            <a:avLst/>
+          </a:prstGeom>
+        </p:spPr>
+      </p:pic>
+      <p:sp>
+        <p:nvSpPr>
+          <p:cNvPr id="11" name="Text 6"/>
+          <p:cNvSpPr/>
+          <p:nvPr/>
+        </p:nvSpPr>
+        <p:spPr>
+          <a:xfrm>
+            <a:off x="3383280" y="3383280"/>
+            <a:ext cx="2377440" cy="365760"/>
+          </a:xfrm>
+          <a:prstGeom prst="rect">
+            <a:avLst/>
+          </a:prstGeom>
+          <a:noFill/>
+          <a:ln/>
+        </p:spPr>
+        <p:txBody>
+          <a:bodyPr wrap="square" lIns="0" tIns="0" rIns="0" bIns="0" rtlCol="0" anchor="ctr"/>
           <a:lstStyle/>
           <a:p>
             <a:pPr algn="ctr" indent="0" marL="0">
               <a:buNone/>
             </a:pPr>
             <a:r>
-              <a:rPr lang="en-US" sz="1050" i="1" dirty="0">
+              <a:rPr lang="en-US" sz="1200" b="1" dirty="0">
                 <a:solidFill>
                   <a:srgbClr val="1F2833"/>
+                </a:solidFill>
+                <a:latin typeface="Cambria" pitchFamily="34" charset="0"/>
+                <a:ea typeface="Cambria" pitchFamily="34" charset="-122"/>
+                <a:cs typeface="Cambria" pitchFamily="34" charset="-120"/>
+              </a:rPr>
+              <a:t>Aspect Sentiment Heatmap</a:t>
+            </a:r>
+            <a:endParaRPr lang="en-US" sz="1200" dirty="0"/>
+          </a:p>
+        </p:txBody>
+      </p:sp>
+      <p:sp>
+        <p:nvSpPr>
+          <p:cNvPr id="12" name="Text 7"/>
+          <p:cNvSpPr/>
+          <p:nvPr/>
+        </p:nvSpPr>
+        <p:spPr>
+          <a:xfrm>
+            <a:off x="3383280" y="3794760"/>
+            <a:ext cx="2377440" cy="731520"/>
+          </a:xfrm>
+          <a:prstGeom prst="rect">
+            <a:avLst/>
+          </a:prstGeom>
+          <a:noFill/>
+          <a:ln/>
+        </p:spPr>
+        <p:txBody>
+          <a:bodyPr wrap="square" lIns="0" tIns="0" rIns="0" bIns="0" rtlCol="0" anchor="ctr"/>
+          <a:lstStyle/>
+          <a:p>
+            <a:pPr algn="ctr" indent="0" marL="0">
+              <a:buNone/>
+            </a:pPr>
+            <a:r>
+              <a:rPr lang="en-US" sz="1050" dirty="0">
+                <a:solidFill>
+                  <a:srgbClr val="64748B"/>
                 </a:solidFill>
                 <a:latin typeface="Calibri" pitchFamily="34" charset="0"/>
                 <a:ea typeface="Calibri" pitchFamily="34" charset="-122"/>
                 <a:cs typeface="Calibri" pitchFamily="34" charset="-120"/>
               </a:rPr>
-              <a:t>[ Streamlit Visualization ]</a:t>
+              <a:t>Displays positive, neutral, and negative metrics across key product aspect features.</a:t>
             </a:r>
             <a:endParaRPr lang="en-US" sz="1050" dirty="0"/>
           </a:p>
@@ -6856,85 +6860,7 @@
       </p:sp>
       <p:sp>
         <p:nvSpPr>
-          <p:cNvPr id="13" name="Text 10"/>
-          <p:cNvSpPr/>
-          <p:nvPr/>
-        </p:nvSpPr>
-        <p:spPr>
-          <a:xfrm>
-            <a:off x="3383280" y="3383280"/>
-            <a:ext cx="2377440" cy="365760"/>
-          </a:xfrm>
-          <a:prstGeom prst="rect">
-            <a:avLst/>
-          </a:prstGeom>
-          <a:noFill/>
-          <a:ln/>
-        </p:spPr>
-        <p:txBody>
-          <a:bodyPr wrap="square" lIns="0" tIns="0" rIns="0" bIns="0" rtlCol="0" anchor="ctr"/>
-          <a:lstStyle/>
-          <a:p>
-            <a:pPr algn="ctr" indent="0" marL="0">
-              <a:buNone/>
-            </a:pPr>
-            <a:r>
-              <a:rPr lang="en-US" sz="1200" b="1" dirty="0">
-                <a:solidFill>
-                  <a:srgbClr val="1F2833"/>
-                </a:solidFill>
-                <a:latin typeface="Cambria" pitchFamily="34" charset="0"/>
-                <a:ea typeface="Cambria" pitchFamily="34" charset="-122"/>
-                <a:cs typeface="Cambria" pitchFamily="34" charset="-120"/>
-              </a:rPr>
-              <a:t>Aspect Sentiment Heatmap</a:t>
-            </a:r>
-            <a:endParaRPr lang="en-US" sz="1200" dirty="0"/>
-          </a:p>
-        </p:txBody>
-      </p:sp>
-      <p:sp>
-        <p:nvSpPr>
-          <p:cNvPr id="14" name="Text 11"/>
-          <p:cNvSpPr/>
-          <p:nvPr/>
-        </p:nvSpPr>
-        <p:spPr>
-          <a:xfrm>
-            <a:off x="3383280" y="3794760"/>
-            <a:ext cx="2377440" cy="731520"/>
-          </a:xfrm>
-          <a:prstGeom prst="rect">
-            <a:avLst/>
-          </a:prstGeom>
-          <a:noFill/>
-          <a:ln/>
-        </p:spPr>
-        <p:txBody>
-          <a:bodyPr wrap="square" lIns="0" tIns="0" rIns="0" bIns="0" rtlCol="0" anchor="ctr"/>
-          <a:lstStyle/>
-          <a:p>
-            <a:pPr algn="ctr" indent="0" marL="0">
-              <a:buNone/>
-            </a:pPr>
-            <a:r>
-              <a:rPr lang="en-US" sz="1050" dirty="0">
-                <a:solidFill>
-                  <a:srgbClr val="64748B"/>
-                </a:solidFill>
-                <a:latin typeface="Calibri" pitchFamily="34" charset="0"/>
-                <a:ea typeface="Calibri" pitchFamily="34" charset="-122"/>
-                <a:cs typeface="Calibri" pitchFamily="34" charset="-120"/>
-              </a:rPr>
-              <a:t>Displays positive, neutral, and negative metrics across key product aspect features.</a:t>
-            </a:r>
-            <a:endParaRPr lang="en-US" sz="1050" dirty="0"/>
-          </a:p>
-        </p:txBody>
-      </p:sp>
-      <p:sp>
-        <p:nvSpPr>
-          <p:cNvPr id="15" name="Shape 12"/>
+          <p:cNvPr id="13" name="Shape 8"/>
           <p:cNvSpPr/>
           <p:nvPr/>
         </p:nvSpPr>
@@ -6961,70 +6887,33 @@
           </a:effectLst>
         </p:spPr>
       </p:sp>
-      <p:sp>
-        <p:nvSpPr>
-          <p:cNvPr id="16" name="Shape 13"/>
-          <p:cNvSpPr/>
-          <p:nvPr/>
-        </p:nvSpPr>
+      <p:pic>
+        <p:nvPicPr>
+          <p:cNvPr id="14" name="Image 3" descr="/Users/amanmeena/Documents/Work/RevuMind/reports/figures/extractive_cohort_summaries.jpg">    </p:cNvPr>
+          <p:cNvPicPr>
+            <a:picLocks noChangeAspect="1"/>
+          </p:cNvPicPr>
+          <p:nvPr/>
+        </p:nvPicPr>
+        <p:blipFill>
+          <a:blip r:embed="rId4"/>
+          <a:stretch>
+            <a:fillRect/>
+          </a:stretch>
+        </p:blipFill>
         <p:spPr>
           <a:xfrm>
             <a:off x="6263640" y="1280160"/>
             <a:ext cx="2286000" cy="1920240"/>
           </a:xfrm>
-          <a:prstGeom prst="roundRect">
-            <a:avLst>
-              <a:gd name="adj" fmla="val 3810"/>
-            </a:avLst>
-          </a:prstGeom>
-          <a:solidFill>
-            <a:srgbClr val="EBF5FB"/>
-          </a:solidFill>
-          <a:ln/>
-        </p:spPr>
-      </p:sp>
-      <p:sp>
-        <p:nvSpPr>
-          <p:cNvPr id="17" name="Text 14"/>
-          <p:cNvSpPr/>
-          <p:nvPr/>
-        </p:nvSpPr>
-        <p:spPr>
-          <a:xfrm>
-            <a:off x="6263640" y="1280160"/>
-            <a:ext cx="2286000" cy="914400"/>
-          </a:xfrm>
-          <a:prstGeom prst="rect">
-            <a:avLst/>
-          </a:prstGeom>
-          <a:noFill/>
-          <a:ln/>
-        </p:spPr>
-        <p:txBody>
-          <a:bodyPr wrap="square" rtlCol="0" anchor="b"/>
-          <a:lstStyle/>
-          <a:p>
-            <a:pPr algn="ctr" indent="0" marL="0">
-              <a:buNone/>
-            </a:pPr>
-            <a:r>
-              <a:rPr lang="en-US" sz="1050" i="1" dirty="0">
-                <a:solidFill>
-                  <a:srgbClr val="1F2833"/>
-                </a:solidFill>
-                <a:latin typeface="Calibri" pitchFamily="34" charset="0"/>
-                <a:ea typeface="Calibri" pitchFamily="34" charset="-122"/>
-                <a:cs typeface="Calibri" pitchFamily="34" charset="-120"/>
-              </a:rPr>
-              <a:t>[ Streamlit Visualization ]</a:t>
-            </a:r>
-            <a:endParaRPr lang="en-US" sz="1050" dirty="0"/>
-          </a:p>
-        </p:txBody>
-      </p:sp>
-      <p:sp>
-        <p:nvSpPr>
-          <p:cNvPr id="18" name="Text 15"/>
+          <a:prstGeom prst="rect">
+            <a:avLst/>
+          </a:prstGeom>
+        </p:spPr>
+      </p:pic>
+      <p:sp>
+        <p:nvSpPr>
+          <p:cNvPr id="15" name="Text 9"/>
           <p:cNvSpPr/>
           <p:nvPr/>
         </p:nvSpPr>
@@ -7063,7 +6952,7 @@
       </p:sp>
       <p:sp>
         <p:nvSpPr>
-          <p:cNvPr id="19" name="Text 16"/>
+          <p:cNvPr id="16" name="Text 10"/>
           <p:cNvSpPr/>
           <p:nvPr/>
         </p:nvSpPr>

</xml_diff>